<commit_message>
Add Modular proposal summary image and clarify Account is not dedicated
Single visual with pricing and deliverables; Account Manager marked as non-dedicated in HTML and PPTX.

Co-authored-by: sarapizzico-hue <sarapizzico-hue@users.noreply.github.com>
</commit_message>
<xml_diff>
--- a/proposta-modular-estruturas.pptx
+++ b/proposta-modular-estruturas.pptx
@@ -5872,7 +5872,7 @@
                 </a:solidFill>
                 <a:latin typeface="Arial"/>
               </a:rPr>
-              <a:t>•  Account Manager orquestrando a operação</a:t>
+              <a:t>•  Account Manager (não dedicado) orquestrando a operação</a:t>
             </a:r>
           </a:p>
           <a:p>
@@ -9856,7 +9856,7 @@
                 </a:solidFill>
                 <a:latin typeface="Arial"/>
               </a:rPr>
-              <a:t>•  Account Manager + Gestão de Tráfego</a:t>
+              <a:t>•  Account Manager (não dedicado) + GT</a:t>
             </a:r>
           </a:p>
           <a:p>

</xml_diff>